<commit_message>
Çıktılar iki dilli: İngilizce not PDF/DOCX ve paket İngilizce kaynaktan
- build_outputs.py: not-pdf, docx ve paket adımları tr ve en için ayrı
  üretir (İngilizce antet, İngilizce başlık); EN kaynağı yoksa TR kopyası
- Alt süreçlere PYTHONUTF8: boruya yönlenen çıktıda cp1252 Türkçe log
  satırı mkdocs derlemesini çökertiyordu
- mkdocs.yml: git eklentileri CEN429_GIT=false ile kapatılabilir (yerel
  denetim derlemesi; varsayılan davranış aynı)
- content.html: git_info tanımsızsa yazar listesi boş geçilir
- 17 birimin sunum ve not çıktıları yeniden üretildi

Co-Authored-By: Claude Opus 5.5 (1M context) <noreply@anthropic.com>
</commit_message>
<xml_diff>
--- a/docs/syllabus/cen429-izlence-sunum.en.pptx
+++ b/docs/syllabus/cen429-izlence-sunum.en.pptx
@@ -3149,7 +3149,7 @@
                   <a:srgbClr val="5B6770"/>
                 </a:solidFill>
               </a:rPr>
-              <a:t>CEN429 Güvenli Programlama · Ders İzlencesi</a:t>
+              <a:t>CEN429 Secure Programming · Syllabus</a:t>
             </a:r>
           </a:p>
         </p:txBody>
@@ -3182,7 +3182,7 @@
                   <a:srgbClr val="5B6770"/>
                 </a:solidFill>
               </a:rPr>
-              <a:t>RTEÜ Bilgisayar Mühendisliği · 2026-2027 Güz</a:t>
+              <a:t>RTEU Computer Engineering · 2026-2027 Fall</a:t>
             </a:r>
           </a:p>
         </p:txBody>
@@ -3216,7 +3216,7 @@
                   <a:srgbClr val="006D77"/>
                 </a:solidFill>
               </a:rPr>
-              <a:t>CEN429 Güvenli Programlama</a:t>
+              <a:t>CEN429 Secure Programming</a:t>
             </a:r>
           </a:p>
         </p:txBody>
@@ -3250,7 +3250,7 @@
                   <a:srgbClr val="1F2D3A"/>
                 </a:solidFill>
               </a:rPr>
-              <a:t>Ders İzlencesi — 2026-2027 Güz</a:t>
+              <a:t>Syllabus — 2026-2027 Fall</a:t>
             </a:r>
           </a:p>
         </p:txBody>
@@ -3284,7 +3284,7 @@
                   <a:srgbClr val="1F2D3A"/>
                 </a:solidFill>
               </a:rPr>
-              <a:t>Dr. Öğr. Üyesi Uğur CORUH</a:t>
+              <a:t>Asst. Prof. Dr. Uğur CORUH</a:t>
             </a:r>
           </a:p>
         </p:txBody>
@@ -3359,7 +3359,7 @@
                   <a:srgbClr val="5B6770"/>
                 </a:solidFill>
               </a:rPr>
-              <a:t>CEN429 Güvenli Programlama · Ders İzlencesi</a:t>
+              <a:t>CEN429 Secure Programming · Syllabus</a:t>
             </a:r>
           </a:p>
         </p:txBody>
@@ -3392,7 +3392,7 @@
                   <a:srgbClr val="5B6770"/>
                 </a:solidFill>
               </a:rPr>
-              <a:t>RTEÜ Bilgisayar Mühendisliği · 2026-2027 Güz</a:t>
+              <a:t>RTEU Computer Engineering · 2026-2027 Fall</a:t>
             </a:r>
           </a:p>
         </p:txBody>
@@ -3460,7 +3460,7 @@
                   <a:srgbClr val="006D77"/>
                 </a:solidFill>
               </a:rPr>
-              <a:t>Soru ve cevap</a:t>
+              <a:t>Questions and answers</a:t>
             </a:r>
           </a:p>
         </p:txBody>
@@ -3494,7 +3494,7 @@
                   <a:srgbClr val="1F2D3A"/>
                 </a:solidFill>
               </a:rPr>
-              <a:t>Ders sitesi:</a:t>
+              <a:t>Course site:</a:t>
             </a:r>
             <a:r>
               <a:rPr sz="2000" b="0">
@@ -3577,7 +3577,7 @@
                   <a:srgbClr val="5B6770"/>
                 </a:solidFill>
               </a:rPr>
-              <a:t>CEN429 Güvenli Programlama · Ders İzlencesi</a:t>
+              <a:t>CEN429 Secure Programming · Syllabus</a:t>
             </a:r>
           </a:p>
         </p:txBody>
@@ -3610,7 +3610,7 @@
                   <a:srgbClr val="5B6770"/>
                 </a:solidFill>
               </a:rPr>
-              <a:t>RTEÜ Bilgisayar Mühendisliği · 2026-2027 Güz</a:t>
+              <a:t>RTEU Computer Engineering · 2026-2027 Fall</a:t>
             </a:r>
           </a:p>
         </p:txBody>
@@ -3677,7 +3677,7 @@
                   <a:srgbClr val="006D77"/>
                 </a:solidFill>
               </a:rPr>
-              <a:t>Ders bilgileri</a:t>
+              <a:t>Course information</a:t>
             </a:r>
           </a:p>
         </p:txBody>
@@ -3692,7 +3692,7 @@
         </p:nvGraphicFramePr>
         <p:xfrm>
           <a:off x="640080" y="1325880"/>
-          <a:ext cx="10911534" cy="2916935"/>
+          <a:ext cx="10911534" cy="3154679"/>
         </p:xfrm>
         <a:graphic>
           <a:graphicData uri="http://schemas.openxmlformats.org/drawingml/2006/table">
@@ -3701,10 +3701,10 @@
                 <a:tableStyleId>{5C22544A-7EE6-4342-B048-85BDC9FD1C3A}</a:tableStyleId>
               </a:tblPr>
               <a:tblGrid>
-                <a:gridCol w="3386338"/>
-                <a:gridCol w="7525196"/>
+                <a:gridCol w="3306525"/>
+                <a:gridCol w="7605009"/>
               </a:tblGrid>
-              <a:tr h="364616">
+              <a:tr h="394334">
                 <a:tc>
                   <a:txBody>
                     <a:bodyPr wrap="square"/>
@@ -3716,7 +3716,7 @@
                             <a:srgbClr val="FFFFFF"/>
                           </a:solidFill>
                         </a:rPr>
-                        <a:t>İletişim</a:t>
+                        <a:t>Contact</a:t>
                       </a:r>
                     </a:p>
                   </a:txBody>
@@ -3737,7 +3737,7 @@
                             <a:srgbClr val="FFFFFF"/>
                           </a:solidFill>
                         </a:rPr>
-                        <a:t>ugur.coruh@erdogan.edu.tr — konu: </a:t>
+                        <a:t>ugur.coruh@erdogan.edu.tr — subject line: </a:t>
                       </a:r>
                       <a:r>
                         <a:rPr sz="1439" b="1">
@@ -3756,7 +3756,7 @@
                   </a:tcPr>
                 </a:tc>
               </a:tr>
-              <a:tr h="364616">
+              <a:tr h="394334">
                 <a:tc>
                   <a:txBody>
                     <a:bodyPr wrap="square"/>
@@ -3768,7 +3768,7 @@
                             <a:srgbClr val="1F2D3A"/>
                           </a:solidFill>
                         </a:rPr>
-                        <a:t>Ofis</a:t>
+                        <a:t>Office</a:t>
                       </a:r>
                     </a:p>
                   </a:txBody>
@@ -3789,7 +3789,7 @@
                             <a:srgbClr val="1F2D3A"/>
                           </a:solidFill>
                         </a:rPr>
-                        <a:t>F-301 · görüşme e-posta ile randevuyla</a:t>
+                        <a:t>F-301 · meetings by e-mail appointment</a:t>
                       </a:r>
                     </a:p>
                   </a:txBody>
@@ -3800,7 +3800,7 @@
                   </a:tcPr>
                 </a:tc>
               </a:tr>
-              <a:tr h="364616">
+              <a:tr h="394334">
                 <a:tc>
                   <a:txBody>
                     <a:bodyPr wrap="square"/>
@@ -3812,7 +3812,7 @@
                             <a:srgbClr val="1F2D3A"/>
                           </a:solidFill>
                         </a:rPr>
-                        <a:t>Ders</a:t>
+                        <a:t>Class</a:t>
                       </a:r>
                     </a:p>
                   </a:txBody>
@@ -3833,7 +3833,7 @@
                             <a:srgbClr val="1F2D3A"/>
                           </a:solidFill>
                         </a:rPr>
-                        <a:t>Cuma 09:00–12:00 · İİBF ve Hukuk Fakültesi Binası, D-402</a:t>
+                        <a:t>Friday 09:00–12:00 · Faculty of Economics and Law Building, D-402</a:t>
                       </a:r>
                     </a:p>
                   </a:txBody>
@@ -3844,7 +3844,7 @@
                   </a:tcPr>
                 </a:tc>
               </a:tr>
-              <a:tr h="364616">
+              <a:tr h="394334">
                 <a:tc>
                   <a:txBody>
                     <a:bodyPr wrap="square"/>
@@ -3856,7 +3856,7 @@
                             <a:srgbClr val="1F2D3A"/>
                           </a:solidFill>
                         </a:rPr>
-                        <a:t>Web sitesi</a:t>
+                        <a:t>Website</a:t>
                       </a:r>
                     </a:p>
                   </a:txBody>
@@ -3888,7 +3888,7 @@
                   </a:tcPr>
                 </a:tc>
               </a:tr>
-              <a:tr h="364616">
+              <a:tr h="394334">
                 <a:tc>
                   <a:txBody>
                     <a:bodyPr wrap="square"/>
@@ -3900,7 +3900,7 @@
                             <a:srgbClr val="1F2D3A"/>
                           </a:solidFill>
                         </a:rPr>
-                        <a:t>Sınıf</a:t>
+                        <a:t>Classroom code</a:t>
                       </a:r>
                     </a:p>
                   </a:txBody>
@@ -3921,7 +3921,7 @@
                             <a:srgbClr val="1F2D3A"/>
                           </a:solidFill>
                         </a:rPr>
-                        <a:t>Her dönem yeni sınıf; kod 1. haftada duyurulur</a:t>
+                        <a:t>A new code each term; announced in week 1</a:t>
                       </a:r>
                     </a:p>
                   </a:txBody>
@@ -3932,7 +3932,7 @@
                   </a:tcPr>
                 </a:tc>
               </a:tr>
-              <a:tr h="364616">
+              <a:tr h="394334">
                 <a:tc>
                   <a:txBody>
                     <a:bodyPr wrap="square"/>
@@ -3944,7 +3944,7 @@
                             <a:srgbClr val="1F2D3A"/>
                           </a:solidFill>
                         </a:rPr>
-                        <a:t>Dil / tür</a:t>
+                        <a:t>Language / type</a:t>
                       </a:r>
                     </a:p>
                   </a:txBody>
@@ -3965,7 +3965,7 @@
                             <a:srgbClr val="1F2D3A"/>
                           </a:solidFill>
                         </a:rPr>
-                        <a:t>Türkçe · Seçmeli · 7. yarıyıl</a:t>
+                        <a:t>Turkish · Elective · 7th semester</a:t>
                       </a:r>
                     </a:p>
                   </a:txBody>
@@ -3976,7 +3976,7 @@
                   </a:tcPr>
                 </a:tc>
               </a:tr>
-              <a:tr h="364616">
+              <a:tr h="394334">
                 <a:tc>
                   <a:txBody>
                     <a:bodyPr wrap="square"/>
@@ -3988,7 +3988,7 @@
                             <a:srgbClr val="1F2D3A"/>
                           </a:solidFill>
                         </a:rPr>
-                        <a:t>Saat / kredi / AKTS</a:t>
+                        <a:t>Hours / credits / ECTS</a:t>
                       </a:r>
                     </a:p>
                   </a:txBody>
@@ -4020,7 +4020,7 @@
                   </a:tcPr>
                 </a:tc>
               </a:tr>
-              <a:tr h="364623">
+              <a:tr h="394341">
                 <a:tc>
                   <a:txBody>
                     <a:bodyPr wrap="square"/>
@@ -4032,7 +4032,7 @@
                             <a:srgbClr val="1F2D3A"/>
                           </a:solidFill>
                         </a:rPr>
-                        <a:t>Ön koşul</a:t>
+                        <a:t>Prerequisite</a:t>
                       </a:r>
                     </a:p>
                   </a:txBody>
@@ -4053,7 +4053,7 @@
                             <a:srgbClr val="1F2D3A"/>
                           </a:solidFill>
                         </a:rPr>
-                        <a:t>CEN107 Algoritmalar ve Programlama I</a:t>
+                        <a:t>CEN107 Algorithms and Programming I</a:t>
                       </a:r>
                     </a:p>
                   </a:txBody>
@@ -4138,7 +4138,7 @@
                   <a:srgbClr val="5B6770"/>
                 </a:solidFill>
               </a:rPr>
-              <a:t>CEN429 Güvenli Programlama · Ders İzlencesi</a:t>
+              <a:t>CEN429 Secure Programming · Syllabus</a:t>
             </a:r>
           </a:p>
         </p:txBody>
@@ -4171,7 +4171,7 @@
                   <a:srgbClr val="5B6770"/>
                 </a:solidFill>
               </a:rPr>
-              <a:t>RTEÜ Bilgisayar Mühendisliği · 2026-2027 Güz</a:t>
+              <a:t>RTEU Computer Engineering · 2026-2027 Fall</a:t>
             </a:r>
           </a:p>
         </p:txBody>
@@ -4238,7 +4238,7 @@
                   <a:srgbClr val="006D77"/>
                 </a:solidFill>
               </a:rPr>
-              <a:t>Dersin amacı</a:t>
+              <a:t>Aim of the course</a:t>
             </a:r>
           </a:p>
         </p:txBody>
@@ -4279,28 +4279,20 @@
               <a:t>• </a:t>
             </a:r>
             <a:r>
+              <a:rPr sz="2000" b="1">
+                <a:solidFill>
+                  <a:srgbClr val="1F2D3A"/>
+                </a:solidFill>
+              </a:rPr>
+              <a:t>Recognise</a:t>
+            </a:r>
+            <a:r>
               <a:rPr sz="2000" b="0">
                 <a:solidFill>
                   <a:srgbClr val="1F2D3A"/>
                 </a:solidFill>
               </a:rPr>
-              <a:t>Yaygın yazılım güvenlik açıklarını </a:t>
-            </a:r>
-            <a:r>
-              <a:rPr sz="2000" b="1">
-                <a:solidFill>
-                  <a:srgbClr val="1F2D3A"/>
-                </a:solidFill>
-              </a:rPr>
-              <a:t>tanımak</a:t>
-            </a:r>
-            <a:r>
-              <a:rPr sz="2000" b="0">
-                <a:solidFill>
-                  <a:srgbClr val="1F2D3A"/>
-                </a:solidFill>
-              </a:rPr>
-              <a:t>: arabellek taşması, bellek hataları, enjeksiyon</a:t>
+              <a:t> common software vulnerabilities: buffer overflow, memory errors, injection</a:t>
             </a:r>
           </a:p>
           <a:p>
@@ -4318,28 +4310,20 @@
               <a:t>• </a:t>
             </a:r>
             <a:r>
+              <a:rPr sz="2000" b="1">
+                <a:solidFill>
+                  <a:srgbClr val="1F2D3A"/>
+                </a:solidFill>
+              </a:rPr>
+              <a:t>Apply</a:t>
+            </a:r>
+            <a:r>
               <a:rPr sz="2000" b="0">
                 <a:solidFill>
                   <a:srgbClr val="1F2D3A"/>
                 </a:solidFill>
               </a:rPr>
-              <a:t>Yazılım koruma yöntemlerini </a:t>
-            </a:r>
-            <a:r>
-              <a:rPr sz="2000" b="1">
-                <a:solidFill>
-                  <a:srgbClr val="1F2D3A"/>
-                </a:solidFill>
-              </a:rPr>
-              <a:t>uygulamak</a:t>
-            </a:r>
-            <a:r>
-              <a:rPr sz="2000" b="0">
-                <a:solidFill>
-                  <a:srgbClr val="1F2D3A"/>
-                </a:solidFill>
-              </a:rPr>
-              <a:t>: veri güvenliği ve kriptografi, C/C++ ve Java sağlamlaştırma,</a:t>
+              <a:t> software protection methods: data security and cryptography, C/C++ and Java hardening,</a:t>
             </a:r>
           </a:p>
         </p:txBody>
@@ -4373,7 +4357,7 @@
                   <a:srgbClr val="1F2D3A"/>
                 </a:solidFill>
               </a:rPr>
-              <a:t>çalışma zamanı öz koruması, kod gizleme, whitebox kriptografi</a:t>
+              <a:t>runtime self-protection, code obfuscation, whitebox cryptography</a:t>
             </a:r>
           </a:p>
         </p:txBody>
@@ -4419,7 +4403,7 @@
                   <a:srgbClr val="1F2D3A"/>
                 </a:solidFill>
               </a:rPr>
-              <a:t>Güvenlik standartlarını ve </a:t>
+              <a:t>Know security standards and </a:t>
             </a:r>
             <a:r>
               <a:rPr sz="2000" b="1">
@@ -4427,15 +4411,7 @@
                   <a:srgbClr val="1F2D3A"/>
                 </a:solidFill>
               </a:rPr>
-              <a:t>sızma testi planlamasını</a:t>
-            </a:r>
-            <a:r>
-              <a:rPr sz="2000" b="0">
-                <a:solidFill>
-                  <a:srgbClr val="1F2D3A"/>
-                </a:solidFill>
-              </a:rPr>
-              <a:t> bilmek</a:t>
+              <a:t>penetration test planning</a:t>
             </a:r>
           </a:p>
           <a:p>
@@ -4458,7 +4434,7 @@
                   <a:srgbClr val="1F2D3A"/>
                 </a:solidFill>
               </a:rPr>
-              <a:t>Her konu: </a:t>
+              <a:t>Every topic: </a:t>
             </a:r>
             <a:r>
               <a:rPr sz="2000" b="1">
@@ -4466,7 +4442,7 @@
                   <a:srgbClr val="1F2D3A"/>
                 </a:solidFill>
               </a:rPr>
-              <a:t>hatalı kod → saldırı → düzeltme</a:t>
+              <a:t>faulty code → attack → fix</a:t>
             </a:r>
           </a:p>
         </p:txBody>
@@ -4541,7 +4517,7 @@
                   <a:srgbClr val="5B6770"/>
                 </a:solidFill>
               </a:rPr>
-              <a:t>CEN429 Güvenli Programlama · Ders İzlencesi</a:t>
+              <a:t>CEN429 Secure Programming · Syllabus</a:t>
             </a:r>
           </a:p>
         </p:txBody>
@@ -4574,7 +4550,7 @@
                   <a:srgbClr val="5B6770"/>
                 </a:solidFill>
               </a:rPr>
-              <a:t>RTEÜ Bilgisayar Mühendisliği · 2026-2027 Güz</a:t>
+              <a:t>RTEU Computer Engineering · 2026-2027 Fall</a:t>
             </a:r>
           </a:p>
         </p:txBody>
@@ -4641,7 +4617,7 @@
                   <a:srgbClr val="006D77"/>
                 </a:solidFill>
               </a:rPr>
-              <a:t>Öğrenme çıktıları</a:t>
+              <a:t>Learning outcomes</a:t>
             </a:r>
           </a:p>
         </p:txBody>
@@ -4665,8 +4641,8 @@
                 <a:tableStyleId>{5C22544A-7EE6-4342-B048-85BDC9FD1C3A}</a:tableStyleId>
               </a:tblPr>
               <a:tblGrid>
-                <a:gridCol w="746087"/>
-                <a:gridCol w="10165447"/>
+                <a:gridCol w="765721"/>
+                <a:gridCol w="10145813"/>
               </a:tblGrid>
               <a:tr h="447827">
                 <a:tc>
@@ -4680,7 +4656,7 @@
                             <a:srgbClr val="FFFFFF"/>
                           </a:solidFill>
                         </a:rPr>
-                        <a:t>Kod</a:t>
+                        <a:t>Code</a:t>
                       </a:r>
                     </a:p>
                   </a:txBody>
@@ -4701,7 +4677,7 @@
                             <a:srgbClr val="FFFFFF"/>
                           </a:solidFill>
                         </a:rPr>
-                        <a:t>Öğrenme çıktısı</a:t>
+                        <a:t>Learning outcome</a:t>
                       </a:r>
                     </a:p>
                   </a:txBody>
@@ -4724,7 +4700,7 @@
                             <a:srgbClr val="1F2D3A"/>
                           </a:solidFill>
                         </a:rPr>
-                        <a:t>ÖÇ.1</a:t>
+                        <a:t>LO.1</a:t>
                       </a:r>
                     </a:p>
                   </a:txBody>
@@ -4745,7 +4721,7 @@
                             <a:srgbClr val="1F2D3A"/>
                           </a:solidFill>
                         </a:rPr>
-                        <a:t>Yaygın güvenlik açıklarını tanımlar ve sınıflandırır</a:t>
+                        <a:t>Identifies and classifies common vulnerabilities</a:t>
                       </a:r>
                     </a:p>
                   </a:txBody>
@@ -4768,7 +4744,7 @@
                             <a:srgbClr val="1F2D3A"/>
                           </a:solidFill>
                         </a:rPr>
-                        <a:t>ÖÇ.2</a:t>
+                        <a:t>LO.2</a:t>
                       </a:r>
                     </a:p>
                   </a:txBody>
@@ -4789,7 +4765,7 @@
                             <a:srgbClr val="1F2D3A"/>
                           </a:solidFill>
                         </a:rPr>
-                        <a:t>Şifreleme yöntemlerini ve güvenli iletişim ilkelerini (SSL/TLS) açıklar</a:t>
+                        <a:t>Explains encryption methods and the principles of secure communication (SSL/TLS)</a:t>
                       </a:r>
                     </a:p>
                   </a:txBody>
@@ -4812,7 +4788,7 @@
                             <a:srgbClr val="1F2D3A"/>
                           </a:solidFill>
                         </a:rPr>
-                        <a:t>ÖÇ.3</a:t>
+                        <a:t>LO.3</a:t>
                       </a:r>
                     </a:p>
                   </a:txBody>
@@ -4833,7 +4809,7 @@
                             <a:srgbClr val="1F2D3A"/>
                           </a:solidFill>
                         </a:rPr>
-                        <a:t>Kod sağlamlaştırma tekniklerini (girdi doğrulama, güvenli bellek, RASP, gizleme) C/C++ ve Java'da uygular</a:t>
+                        <a:t>Applies code hardening techniques (input validation, safe memory, RASP, obfuscation) in C/C++ and Java</a:t>
                       </a:r>
                     </a:p>
                   </a:txBody>
@@ -4856,7 +4832,7 @@
                             <a:srgbClr val="1F2D3A"/>
                           </a:solidFill>
                         </a:rPr>
-                        <a:t>ÖÇ.4</a:t>
+                        <a:t>LO.4</a:t>
                       </a:r>
                     </a:p>
                   </a:txBody>
@@ -4877,7 +4853,7 @@
                             <a:srgbClr val="1F2D3A"/>
                           </a:solidFill>
                         </a:rPr>
-                        <a:t>Şifreleme ve kimlik doğrulamayla güvenli kanal kurma ilkelerini açıklar</a:t>
+                        <a:t>Explains how to build a secure channel with encryption and authentication</a:t>
                       </a:r>
                     </a:p>
                   </a:txBody>
@@ -4900,7 +4876,7 @@
                             <a:srgbClr val="1F2D3A"/>
                           </a:solidFill>
                         </a:rPr>
-                        <a:t>ÖÇ.5</a:t>
+                        <a:t>LO.5</a:t>
                       </a:r>
                     </a:p>
                   </a:txBody>
@@ -4921,7 +4897,7 @@
                             <a:srgbClr val="1F2D3A"/>
                           </a:solidFill>
                         </a:rPr>
-                        <a:t>Güvenli tasarım ilkeleriyle yazılım planı oluşturur</a:t>
+                        <a:t>Produces a software plan based on secure design principles</a:t>
                       </a:r>
                     </a:p>
                   </a:txBody>
@@ -4944,7 +4920,7 @@
                             <a:srgbClr val="1F2D3A"/>
                           </a:solidFill>
                         </a:rPr>
-                        <a:t>ÖÇ.6</a:t>
+                        <a:t>LO.6</a:t>
                       </a:r>
                     </a:p>
                   </a:txBody>
@@ -4965,7 +4941,7 @@
                             <a:srgbClr val="1F2D3A"/>
                           </a:solidFill>
                         </a:rPr>
-                        <a:t>Güvenlik incelemesi ve zafiyet değerlendirme yöntemlerini bilir</a:t>
+                        <a:t>Knows security review and vulnerability assessment methods</a:t>
                       </a:r>
                     </a:p>
                   </a:txBody>
@@ -4988,7 +4964,7 @@
                             <a:srgbClr val="1F2D3A"/>
                           </a:solidFill>
                         </a:rPr>
-                        <a:t>ÖÇ.7</a:t>
+                        <a:t>LO.7</a:t>
                       </a:r>
                     </a:p>
                   </a:txBody>
@@ -5009,7 +4985,7 @@
                             <a:srgbClr val="1F2D3A"/>
                           </a:solidFill>
                         </a:rPr>
-                        <a:t>Güvenli programlama standartlarını ve sızma testi planlamasını bilir</a:t>
+                        <a:t>Knows secure programming standards and penetration test planning</a:t>
                       </a:r>
                     </a:p>
                   </a:txBody>
@@ -5094,7 +5070,7 @@
                   <a:srgbClr val="5B6770"/>
                 </a:solidFill>
               </a:rPr>
-              <a:t>CEN429 Güvenli Programlama · Ders İzlencesi</a:t>
+              <a:t>CEN429 Secure Programming · Syllabus</a:t>
             </a:r>
           </a:p>
         </p:txBody>
@@ -5127,7 +5103,7 @@
                   <a:srgbClr val="5B6770"/>
                 </a:solidFill>
               </a:rPr>
-              <a:t>RTEÜ Bilgisayar Mühendisliği · 2026-2027 Güz</a:t>
+              <a:t>RTEU Computer Engineering · 2026-2027 Fall</a:t>
             </a:r>
           </a:p>
         </p:txBody>
@@ -5194,7 +5170,7 @@
                   <a:srgbClr val="006D77"/>
                 </a:solidFill>
               </a:rPr>
-              <a:t>Haftalık program (1–8)</a:t>
+              <a:t>Weekly schedule (1–8)</a:t>
             </a:r>
           </a:p>
         </p:txBody>
@@ -5209,7 +5185,7 @@
         </p:nvGraphicFramePr>
         <p:xfrm>
           <a:off x="640080" y="1325880"/>
-          <a:ext cx="10911533" cy="3692347"/>
+          <a:ext cx="10911533" cy="3478377"/>
         </p:xfrm>
         <a:graphic>
           <a:graphicData uri="http://schemas.openxmlformats.org/drawingml/2006/table">
@@ -5218,11 +5194,11 @@
                 <a:tableStyleId>{5C22544A-7EE6-4342-B048-85BDC9FD1C3A}</a:tableStyleId>
               </a:tblPr>
               <a:tblGrid>
-                <a:gridCol w="850249"/>
-                <a:gridCol w="2125623"/>
-                <a:gridCol w="7935661"/>
+                <a:gridCol w="689149"/>
+                <a:gridCol w="1722873"/>
+                <a:gridCol w="8499511"/>
               </a:tblGrid>
-              <a:tr h="410260">
+              <a:tr h="386486">
                 <a:tc>
                   <a:txBody>
                     <a:bodyPr wrap="square"/>
@@ -5234,7 +5210,7 @@
                             <a:srgbClr val="FFFFFF"/>
                           </a:solidFill>
                         </a:rPr>
-                        <a:t>Hf</a:t>
+                        <a:t>Wk</a:t>
                       </a:r>
                     </a:p>
                   </a:txBody>
@@ -5255,7 +5231,7 @@
                             <a:srgbClr val="FFFFFF"/>
                           </a:solidFill>
                         </a:rPr>
-                        <a:t>Tarih</a:t>
+                        <a:t>Date</a:t>
                       </a:r>
                     </a:p>
                   </a:txBody>
@@ -5276,7 +5252,7 @@
                             <a:srgbClr val="FFFFFF"/>
                           </a:solidFill>
                         </a:rPr>
-                        <a:t>Konu</a:t>
+                        <a:t>Topic</a:t>
                       </a:r>
                     </a:p>
                   </a:txBody>
@@ -5287,7 +5263,7 @@
                   </a:tcPr>
                 </a:tc>
               </a:tr>
-              <a:tr h="410260">
+              <a:tr h="386486">
                 <a:tc>
                   <a:txBody>
                     <a:bodyPr wrap="square"/>
@@ -5341,7 +5317,7 @@
                             <a:srgbClr val="1F2D3A"/>
                           </a:solidFill>
                         </a:rPr>
-                        <a:t>Güvenli programlamaya giriş ve uygulama koruma planı</a:t>
+                        <a:t>Introduction to secure programming and the application protection plan</a:t>
                       </a:r>
                     </a:p>
                   </a:txBody>
@@ -5352,7 +5328,7 @@
                   </a:tcPr>
                 </a:tc>
               </a:tr>
-              <a:tr h="410260">
+              <a:tr h="386486">
                 <a:tc>
                   <a:txBody>
                     <a:bodyPr wrap="square"/>
@@ -5406,7 +5382,7 @@
                             <a:srgbClr val="1F2D3A"/>
                           </a:solidFill>
                         </a:rPr>
-                        <a:t>Bilgisayar virüsleri ve güvenlik modelleri</a:t>
+                        <a:t>Computer viruses and security models</a:t>
                       </a:r>
                     </a:p>
                   </a:txBody>
@@ -5417,7 +5393,7 @@
                   </a:tcPr>
                 </a:tc>
               </a:tr>
-              <a:tr h="410260">
+              <a:tr h="386486">
                 <a:tc>
                   <a:txBody>
                     <a:bodyPr wrap="square"/>
@@ -5471,7 +5447,7 @@
                             <a:srgbClr val="1F2D3A"/>
                           </a:solidFill>
                         </a:rPr>
-                        <a:t>Veri güvenliği: aktarımda, beklemede, kullanımda</a:t>
+                        <a:t>Data security: in transit, at rest, in use</a:t>
                       </a:r>
                     </a:p>
                   </a:txBody>
@@ -5482,7 +5458,7 @@
                   </a:tcPr>
                 </a:tc>
               </a:tr>
-              <a:tr h="410260">
+              <a:tr h="386486">
                 <a:tc>
                   <a:txBody>
                     <a:bodyPr wrap="square"/>
@@ -5536,7 +5512,7 @@
                             <a:srgbClr val="1F2D3A"/>
                           </a:solidFill>
                         </a:rPr>
-                        <a:t>Kod sağlamlaştırma: C/C++</a:t>
+                        <a:t>Code hardening: C/C++</a:t>
                       </a:r>
                     </a:p>
                   </a:txBody>
@@ -5547,7 +5523,7 @@
                   </a:tcPr>
                 </a:tc>
               </a:tr>
-              <a:tr h="410260">
+              <a:tr h="386486">
                 <a:tc>
                   <a:txBody>
                     <a:bodyPr wrap="square"/>
@@ -5601,7 +5577,7 @@
                             <a:srgbClr val="1F2D3A"/>
                           </a:solidFill>
                         </a:rPr>
-                        <a:t>Kod sağlamlaştırma: Java ve yorumlanan diller</a:t>
+                        <a:t>Code hardening: Java and interpreted languages</a:t>
                       </a:r>
                     </a:p>
                   </a:txBody>
@@ -5612,7 +5588,7 @@
                   </a:tcPr>
                 </a:tc>
               </a:tr>
-              <a:tr h="410260">
+              <a:tr h="386486">
                 <a:tc>
                   <a:txBody>
                     <a:bodyPr wrap="square"/>
@@ -5666,7 +5642,7 @@
                             <a:srgbClr val="1F2D3A"/>
                           </a:solidFill>
                         </a:rPr>
-                        <a:t>Çalışma zamanı uygulama öz koruması (RASP)</a:t>
+                        <a:t>Runtime application self-protection (RASP)</a:t>
                       </a:r>
                     </a:p>
                   </a:txBody>
@@ -5677,7 +5653,7 @@
                   </a:tcPr>
                 </a:tc>
               </a:tr>
-              <a:tr h="410260">
+              <a:tr h="386486">
                 <a:tc>
                   <a:txBody>
                     <a:bodyPr wrap="square"/>
@@ -5731,7 +5707,7 @@
                             <a:srgbClr val="1F2D3A"/>
                           </a:solidFill>
                         </a:rPr>
-                        <a:t>Ara proje gösterimleri</a:t>
+                        <a:t>Midterm project demonstrations</a:t>
                       </a:r>
                     </a:p>
                   </a:txBody>
@@ -5742,7 +5718,7 @@
                   </a:tcPr>
                 </a:tc>
               </a:tr>
-              <a:tr h="410267">
+              <a:tr h="386489">
                 <a:tc>
                   <a:txBody>
                     <a:bodyPr wrap="square"/>
@@ -5796,7 +5772,7 @@
                             <a:srgbClr val="1F2D3A"/>
                           </a:solidFill>
                         </a:rPr>
-                        <a:t>Ara sınav haftası — Quiz-1</a:t>
+                        <a:t>Midterm exam week — Quiz-1</a:t>
                       </a:r>
                     </a:p>
                   </a:txBody>
@@ -5881,7 +5857,7 @@
                   <a:srgbClr val="5B6770"/>
                 </a:solidFill>
               </a:rPr>
-              <a:t>CEN429 Güvenli Programlama · Ders İzlencesi</a:t>
+              <a:t>CEN429 Secure Programming · Syllabus</a:t>
             </a:r>
           </a:p>
         </p:txBody>
@@ -5914,7 +5890,7 @@
                   <a:srgbClr val="5B6770"/>
                 </a:solidFill>
               </a:rPr>
-              <a:t>RTEÜ Bilgisayar Mühendisliği · 2026-2027 Güz</a:t>
+              <a:t>RTEU Computer Engineering · 2026-2027 Fall</a:t>
             </a:r>
           </a:p>
         </p:txBody>
@@ -5981,7 +5957,7 @@
                   <a:srgbClr val="006D77"/>
                 </a:solidFill>
               </a:rPr>
-              <a:t>Haftalık program (9–16)</a:t>
+              <a:t>Weekly schedule (9–16)</a:t>
             </a:r>
           </a:p>
         </p:txBody>
@@ -5996,7 +5972,7 @@
         </p:nvGraphicFramePr>
         <p:xfrm>
           <a:off x="640080" y="1325880"/>
-          <a:ext cx="10911534" cy="3264408"/>
+          <a:ext cx="10911533" cy="3264408"/>
         </p:xfrm>
         <a:graphic>
           <a:graphicData uri="http://schemas.openxmlformats.org/drawingml/2006/table">
@@ -6005,9 +5981,9 @@
                 <a:tableStyleId>{5C22544A-7EE6-4342-B048-85BDC9FD1C3A}</a:tableStyleId>
               </a:tblPr>
               <a:tblGrid>
-                <a:gridCol w="884719"/>
-                <a:gridCol w="1769438"/>
-                <a:gridCol w="8257377"/>
+                <a:gridCol w="872922"/>
+                <a:gridCol w="1745845"/>
+                <a:gridCol w="8292766"/>
               </a:tblGrid>
               <a:tr h="362712">
                 <a:tc>
@@ -6021,7 +5997,7 @@
                             <a:srgbClr val="FFFFFF"/>
                           </a:solidFill>
                         </a:rPr>
-                        <a:t>Hf</a:t>
+                        <a:t>Wk</a:t>
                       </a:r>
                     </a:p>
                   </a:txBody>
@@ -6042,7 +6018,7 @@
                             <a:srgbClr val="FFFFFF"/>
                           </a:solidFill>
                         </a:rPr>
-                        <a:t>Tarih</a:t>
+                        <a:t>Date</a:t>
                       </a:r>
                     </a:p>
                   </a:txBody>
@@ -6063,7 +6039,7 @@
                             <a:srgbClr val="FFFFFF"/>
                           </a:solidFill>
                         </a:rPr>
-                        <a:t>Konu</a:t>
+                        <a:t>Topic</a:t>
                       </a:r>
                     </a:p>
                   </a:txBody>
@@ -6128,7 +6104,7 @@
                             <a:srgbClr val="1F2D3A"/>
                           </a:solidFill>
                         </a:rPr>
-                        <a:t>Gelişmiş kod gizleme ve çeşitlendirme</a:t>
+                        <a:t>Advanced obfuscation and diversification</a:t>
                       </a:r>
                     </a:p>
                   </a:txBody>
@@ -6193,7 +6169,7 @@
                             <a:srgbClr val="1F2D3A"/>
                           </a:solidFill>
                         </a:rPr>
-                        <a:t>Sertifikalar ve kriptografik yöntemler</a:t>
+                        <a:t>Certificates and cryptographic methods</a:t>
                       </a:r>
                     </a:p>
                   </a:txBody>
@@ -6258,7 +6234,7 @@
                             <a:srgbClr val="1F2D3A"/>
                           </a:solidFill>
                         </a:rPr>
-                        <a:t>Whitebox kriptografi</a:t>
+                        <a:t>Whitebox cryptography</a:t>
                       </a:r>
                     </a:p>
                   </a:txBody>
@@ -6323,7 +6299,7 @@
                             <a:srgbClr val="1F2D3A"/>
                           </a:solidFill>
                         </a:rPr>
-                        <a:t>Güvenlik sertifikasyonları ve sızma testi planlaması</a:t>
+                        <a:t>Security certifications and penetration test planning</a:t>
                       </a:r>
                     </a:p>
                   </a:txBody>
@@ -6388,7 +6364,7 @@
                             <a:srgbClr val="1F2D3A"/>
                           </a:solidFill>
                         </a:rPr>
-                        <a:t>Güvenlik gereksinimleri</a:t>
+                        <a:t>Security requirements</a:t>
                       </a:r>
                     </a:p>
                   </a:txBody>
@@ -6453,7 +6429,7 @@
                             <a:srgbClr val="1F2D3A"/>
                           </a:solidFill>
                         </a:rPr>
-                        <a:t>Tigress ve çeşitlendirme</a:t>
+                        <a:t>Tigress and diversification</a:t>
                       </a:r>
                     </a:p>
                   </a:txBody>
@@ -6518,7 +6494,7 @@
                             <a:srgbClr val="1F2D3A"/>
                           </a:solidFill>
                         </a:rPr>
-                        <a:t>Final proje gösterimleri</a:t>
+                        <a:t>Final project demonstrations</a:t>
                       </a:r>
                     </a:p>
                   </a:txBody>
@@ -6583,7 +6559,7 @@
                             <a:srgbClr val="1F2D3A"/>
                           </a:solidFill>
                         </a:rPr>
-                        <a:t>Final dönemi — Quiz-2</a:t>
+                        <a:t>Final exam period — Quiz-2</a:t>
                       </a:r>
                     </a:p>
                   </a:txBody>
@@ -6668,7 +6644,7 @@
                   <a:srgbClr val="5B6770"/>
                 </a:solidFill>
               </a:rPr>
-              <a:t>CEN429 Güvenli Programlama · Ders İzlencesi</a:t>
+              <a:t>CEN429 Secure Programming · Syllabus</a:t>
             </a:r>
           </a:p>
         </p:txBody>
@@ -6701,7 +6677,7 @@
                   <a:srgbClr val="5B6770"/>
                 </a:solidFill>
               </a:rPr>
-              <a:t>RTEÜ Bilgisayar Mühendisliği · 2026-2027 Güz</a:t>
+              <a:t>RTEU Computer Engineering · 2026-2027 Fall</a:t>
             </a:r>
           </a:p>
         </p:txBody>
@@ -6768,7 +6744,7 @@
                   <a:srgbClr val="006D77"/>
                 </a:solidFill>
               </a:rPr>
-              <a:t>Değerlendirme</a:t>
+              <a:t>Assessment</a:t>
             </a:r>
           </a:p>
         </p:txBody>
@@ -6814,7 +6790,7 @@
                   <a:srgbClr val="1F2D3A"/>
                 </a:solidFill>
               </a:rPr>
-              <a:t>Tek dönem projesi:</a:t>
+              <a:t>One term project:</a:t>
             </a:r>
             <a:r>
               <a:rPr sz="2000" b="0">
@@ -6822,7 +6798,7 @@
                   <a:srgbClr val="1F2D3A"/>
                 </a:solidFill>
               </a:rPr>
-              <a:t> C/C++ uygulaması + güvenlik kılavuzu, iki kontrol noktası (rubrikli)</a:t>
+              <a:t> a C/C++ application + a security guide, with two checkpoints (rubric-based)</a:t>
             </a:r>
           </a:p>
           <a:p>
@@ -6845,7 +6821,7 @@
                   <a:srgbClr val="1F2D3A"/>
                 </a:solidFill>
               </a:rPr>
-              <a:t>İki quiz:</a:t>
+              <a:t>Two quizzes:</a:t>
             </a:r>
             <a:r>
               <a:rPr sz="2000" b="0">
@@ -6853,7 +6829,7 @@
                   <a:srgbClr val="1F2D3A"/>
                 </a:solidFill>
               </a:rPr>
-              <a:t> sınav haftalarında</a:t>
+              <a:t> in the exam weeks</a:t>
             </a:r>
           </a:p>
         </p:txBody>
@@ -6868,7 +6844,7 @@
         </p:nvGraphicFramePr>
         <p:xfrm>
           <a:off x="640080" y="2609088"/>
-          <a:ext cx="10365956" cy="1874519"/>
+          <a:ext cx="10911534" cy="1874519"/>
         </p:xfrm>
         <a:graphic>
           <a:graphicData uri="http://schemas.openxmlformats.org/drawingml/2006/table">
@@ -6877,9 +6853,9 @@
                 <a:tableStyleId>{5C22544A-7EE6-4342-B048-85BDC9FD1C3A}</a:tableStyleId>
               </a:tblPr>
               <a:tblGrid>
-                <a:gridCol w="4910190"/>
-                <a:gridCol w="3091601"/>
-                <a:gridCol w="2364165"/>
+                <a:gridCol w="5285274"/>
+                <a:gridCol w="3750840"/>
+                <a:gridCol w="1875420"/>
               </a:tblGrid>
               <a:tr h="374903">
                 <a:tc>
@@ -6893,7 +6869,7 @@
                             <a:srgbClr val="FFFFFF"/>
                           </a:solidFill>
                         </a:rPr>
-                        <a:t>Bileşen</a:t>
+                        <a:t>Component</a:t>
                       </a:r>
                     </a:p>
                   </a:txBody>
@@ -6914,7 +6890,7 @@
                             <a:srgbClr val="FFFFFF"/>
                           </a:solidFill>
                         </a:rPr>
-                        <a:t>Ağırlık</a:t>
+                        <a:t>Weight</a:t>
                       </a:r>
                     </a:p>
                   </a:txBody>
@@ -6935,7 +6911,7 @@
                             <a:srgbClr val="FFFFFF"/>
                           </a:solidFill>
                         </a:rPr>
-                        <a:t>Zaman</a:t>
+                        <a:t>When</a:t>
                       </a:r>
                     </a:p>
                   </a:txBody>
@@ -6958,7 +6934,7 @@
                             <a:srgbClr val="1F2D3A"/>
                           </a:solidFill>
                         </a:rPr>
-                        <a:t>Proje kontrolü 1 (RAP1)</a:t>
+                        <a:t>Project checkpoint 1 (RAP1)</a:t>
                       </a:r>
                     </a:p>
                   </a:txBody>
@@ -6979,7 +6955,7 @@
                             <a:srgbClr val="1F2D3A"/>
                           </a:solidFill>
                         </a:rPr>
-                        <a:t>Vizenin %60'ı</a:t>
+                        <a:t>60% of the midterm</a:t>
                       </a:r>
                     </a:p>
                   </a:txBody>
@@ -7000,7 +6976,7 @@
                             <a:srgbClr val="1F2D3A"/>
                           </a:solidFill>
                         </a:rPr>
-                        <a:t>7. hafta</a:t>
+                        <a:t>Week 7</a:t>
                       </a:r>
                     </a:p>
                   </a:txBody>
@@ -7044,7 +7020,7 @@
                             <a:srgbClr val="1F2D3A"/>
                           </a:solidFill>
                         </a:rPr>
-                        <a:t>Vizenin %40'ı</a:t>
+                        <a:t>40% of the midterm</a:t>
                       </a:r>
                     </a:p>
                   </a:txBody>
@@ -7065,7 +7041,7 @@
                             <a:srgbClr val="1F2D3A"/>
                           </a:solidFill>
                         </a:rPr>
-                        <a:t>8. hafta</a:t>
+                        <a:t>Week 8</a:t>
                       </a:r>
                     </a:p>
                   </a:txBody>
@@ -7088,7 +7064,7 @@
                             <a:srgbClr val="1F2D3A"/>
                           </a:solidFill>
                         </a:rPr>
-                        <a:t>Proje kontrolü 2 (RAP2)</a:t>
+                        <a:t>Project checkpoint 2 (RAP2)</a:t>
                       </a:r>
                     </a:p>
                   </a:txBody>
@@ -7109,7 +7085,7 @@
                             <a:srgbClr val="1F2D3A"/>
                           </a:solidFill>
                         </a:rPr>
-                        <a:t>Finalin %70'i</a:t>
+                        <a:t>70% of the final</a:t>
                       </a:r>
                     </a:p>
                   </a:txBody>
@@ -7130,7 +7106,7 @@
                             <a:srgbClr val="1F2D3A"/>
                           </a:solidFill>
                         </a:rPr>
-                        <a:t>15. hafta</a:t>
+                        <a:t>Week 15</a:t>
                       </a:r>
                     </a:p>
                   </a:txBody>
@@ -7174,7 +7150,7 @@
                             <a:srgbClr val="1F2D3A"/>
                           </a:solidFill>
                         </a:rPr>
-                        <a:t>Finalin %30'u</a:t>
+                        <a:t>30% of the final</a:t>
                       </a:r>
                     </a:p>
                   </a:txBody>
@@ -7195,7 +7171,7 @@
                             <a:srgbClr val="1F2D3A"/>
                           </a:solidFill>
                         </a:rPr>
-                        <a:t>16. hafta</a:t>
+                        <a:t>Week 16</a:t>
                       </a:r>
                     </a:p>
                   </a:txBody>
@@ -7239,7 +7215,7 @@
                   <a:srgbClr val="1F2D3A"/>
                 </a:solidFill>
               </a:rPr>
-              <a:t>Başarı notu = 0,4 · Vize + 0,6 · Final</a:t>
+              <a:t>Course grade = 0.4 · Midterm + 0.6 · Final</a:t>
             </a:r>
           </a:p>
         </p:txBody>
@@ -7314,7 +7290,7 @@
                   <a:srgbClr val="5B6770"/>
                 </a:solidFill>
               </a:rPr>
-              <a:t>CEN429 Güvenli Programlama · Ders İzlencesi</a:t>
+              <a:t>CEN429 Secure Programming · Syllabus</a:t>
             </a:r>
           </a:p>
         </p:txBody>
@@ -7347,7 +7323,7 @@
                   <a:srgbClr val="5B6770"/>
                 </a:solidFill>
               </a:rPr>
-              <a:t>RTEÜ Bilgisayar Mühendisliği · 2026-2027 Güz</a:t>
+              <a:t>RTEU Computer Engineering · 2026-2027 Fall</a:t>
             </a:r>
           </a:p>
         </p:txBody>
@@ -7414,7 +7390,7 @@
                   <a:srgbClr val="006D77"/>
                 </a:solidFill>
               </a:rPr>
-              <a:t>Kaynaklar ve araçlar</a:t>
+              <a:t>Resources and tools</a:t>
             </a:r>
           </a:p>
         </p:txBody>
@@ -7428,7 +7404,7 @@
         <p:spPr>
           <a:xfrm>
             <a:off x="640080" y="1325880"/>
-            <a:ext cx="10911535" cy="2631440"/>
+            <a:ext cx="10911535" cy="2961640"/>
           </a:xfrm>
           <a:prstGeom prst="rect">
             <a:avLst/>
@@ -7460,7 +7436,7 @@
                   <a:srgbClr val="1F2D3A"/>
                 </a:solidFill>
               </a:rPr>
-              <a:t>Ders notları</a:t>
+              <a:t>Lecture notes</a:t>
             </a:r>
             <a:r>
               <a:rPr sz="2000" b="0">
@@ -7468,7 +7444,7 @@
                   <a:srgbClr val="1F2D3A"/>
                 </a:solidFill>
               </a:rPr>
-              <a:t> (web sitesi) — ana kaynak, kendi başına yeterli</a:t>
+              <a:t> (website) — the main source, sufficient on their own</a:t>
             </a:r>
           </a:p>
           <a:p>
@@ -7491,7 +7467,7 @@
                   <a:srgbClr val="1F2D3A"/>
                 </a:solidFill>
               </a:rPr>
-              <a:t>Ders kitabı:</a:t>
+              <a:t>Textbook:</a:t>
             </a:r>
             <a:r>
               <a:rPr sz="2000" b="0">
@@ -7538,7 +7514,7 @@
                   <a:srgbClr val="1F2D3A"/>
                 </a:solidFill>
               </a:rPr>
-              <a:t>Açık standartlar:</a:t>
+              <a:t>Open standards:</a:t>
             </a:r>
             <a:r>
               <a:rPr sz="2000" b="0">
@@ -7569,7 +7545,7 @@
                   <a:srgbClr val="1F2D3A"/>
                 </a:solidFill>
               </a:rPr>
-              <a:t>Dizüstü bilgisayar gerekli:</a:t>
+              <a:t>A laptop is required:</a:t>
             </a:r>
             <a:r>
               <a:rPr sz="2000" b="0">
@@ -7600,7 +7576,7 @@
                   <a:srgbClr val="1F2D3A"/>
                 </a:solidFill>
               </a:rPr>
-              <a:t>Demolar: </a:t>
+              <a:t>Demos: in the </a:t>
             </a:r>
             <a:r>
               <a:rPr sz="2000" b="0">
@@ -7617,7 +7593,7 @@
                   <a:srgbClr val="1F2D3A"/>
                 </a:solidFill>
               </a:rPr>
-              <a:t> klasörlerinde, her biri </a:t>
+              <a:t> folders; build once inside </a:t>
             </a:r>
             <a:r>
               <a:rPr sz="2000" b="0">
@@ -7626,7 +7602,49 @@
                 </a:solidFill>
                 <a:latin typeface="Consolas"/>
               </a:rPr>
-              <a:t>make demo</a:t>
+              <a:t>code</a:t>
+            </a:r>
+            <a:r>
+              <a:rPr sz="2000" b="0">
+                <a:solidFill>
+                  <a:srgbClr val="1F2D3A"/>
+                </a:solidFill>
+              </a:rPr>
+              <a:t>, then run </a:t>
+            </a:r>
+            <a:r>
+              <a:rPr sz="2000" b="0">
+                <a:solidFill>
+                  <a:srgbClr val="A1123F"/>
+                </a:solidFill>
+                <a:latin typeface="Consolas"/>
+              </a:rPr>
+              <a:t>demo.ps1</a:t>
+            </a:r>
+            <a:r>
+              <a:rPr sz="2000" b="0">
+                <a:solidFill>
+                  <a:srgbClr val="1F2D3A"/>
+                </a:solidFill>
+              </a:rPr>
+              <a:t> (Windows) or </a:t>
+            </a:r>
+            <a:r>
+              <a:rPr sz="2000" b="0">
+                <a:solidFill>
+                  <a:srgbClr val="A1123F"/>
+                </a:solidFill>
+                <a:latin typeface="Consolas"/>
+              </a:rPr>
+              <a:t>demo.sh</a:t>
+            </a:r>
+            <a:r>
+              <a:rPr sz="2000" b="0">
+                <a:solidFill>
+                  <a:srgbClr val="1F2D3A"/>
+                </a:solidFill>
+              </a:rPr>
+              <a:t> (WSL/Linux)</a:t>
             </a:r>
           </a:p>
         </p:txBody>
@@ -7701,7 +7719,7 @@
                   <a:srgbClr val="5B6770"/>
                 </a:solidFill>
               </a:rPr>
-              <a:t>CEN429 Güvenli Programlama · Ders İzlencesi</a:t>
+              <a:t>CEN429 Secure Programming · Syllabus</a:t>
             </a:r>
           </a:p>
         </p:txBody>
@@ -7734,7 +7752,7 @@
                   <a:srgbClr val="5B6770"/>
                 </a:solidFill>
               </a:rPr>
-              <a:t>RTEÜ Bilgisayar Mühendisliği · 2026-2027 Güz</a:t>
+              <a:t>RTEU Computer Engineering · 2026-2027 Fall</a:t>
             </a:r>
           </a:p>
         </p:txBody>
@@ -7801,7 +7819,7 @@
                   <a:srgbClr val="006D77"/>
                 </a:solidFill>
               </a:rPr>
-              <a:t>Kurallar</a:t>
+              <a:t>Rules</a:t>
             </a:r>
           </a:p>
         </p:txBody>
@@ -7847,7 +7865,7 @@
                   <a:srgbClr val="1F2D3A"/>
                 </a:solidFill>
               </a:rPr>
-              <a:t>Geç teslim kabul edilmez</a:t>
+              <a:t>Late submissions are not accepted</a:t>
             </a:r>
             <a:r>
               <a:rPr sz="2000" b="0">
@@ -7855,7 +7873,7 @@
                   <a:srgbClr val="1F2D3A"/>
                 </a:solidFill>
               </a:rPr>
-              <a:t>; beklenmedik durumlar hemen bildirilir</a:t>
+              <a:t>; report unexpected circumstances immediately</a:t>
             </a:r>
           </a:p>
           <a:p>
@@ -7878,7 +7896,7 @@
                   <a:srgbClr val="1F2D3A"/>
                 </a:solidFill>
               </a:rPr>
-              <a:t>Akademik dürüstlük:</a:t>
+              <a:t>Academic integrity:</a:t>
             </a:r>
             <a:r>
               <a:rPr sz="2000" b="0">
@@ -7886,7 +7904,7 @@
                   <a:srgbClr val="1F2D3A"/>
                 </a:solidFill>
               </a:rPr>
-              <a:t> birlikte çalışmak serbest, çözüm paylaşmak ve kaynaksız alıntı yasak</a:t>
+              <a:t> working together is allowed; sharing solutions and uncited quoting are not</a:t>
             </a:r>
           </a:p>
           <a:p>
@@ -7909,7 +7927,7 @@
                   <a:srgbClr val="1F2D3A"/>
                 </a:solidFill>
               </a:rPr>
-              <a:t>İletişim:</a:t>
+              <a:t>Communication:</a:t>
             </a:r>
             <a:r>
               <a:rPr sz="2000" b="0">
@@ -7917,7 +7935,7 @@
                   <a:srgbClr val="1F2D3A"/>
                 </a:solidFill>
               </a:rPr>
-              <a:t> üniversite e-postası, konu satırında </a:t>
+              <a:t> university e-mail, with </a:t>
             </a:r>
             <a:r>
               <a:rPr sz="2000" b="1">
@@ -7926,6 +7944,14 @@
                 </a:solidFill>
               </a:rPr>
               <a:t>[CEN429]</a:t>
+            </a:r>
+            <a:r>
+              <a:rPr sz="2000" b="0">
+                <a:solidFill>
+                  <a:srgbClr val="1F2D3A"/>
+                </a:solidFill>
+              </a:rPr>
+              <a:t> in the subject line</a:t>
             </a:r>
           </a:p>
           <a:p>
@@ -7948,7 +7974,7 @@
                   <a:srgbClr val="1F2D3A"/>
                 </a:solidFill>
               </a:rPr>
-              <a:t>Etik:</a:t>
+              <a:t>Ethics:</a:t>
             </a:r>
             <a:r>
               <a:rPr sz="2000" b="0">
@@ -7956,7 +7982,7 @@
                   <a:srgbClr val="1F2D3A"/>
                 </a:solidFill>
               </a:rPr>
-              <a:t> saldırı teknikleri yalnız </a:t>
+              <a:t> attack techniques are tried </a:t>
             </a:r>
             <a:r>
               <a:rPr sz="2000" b="1">
@@ -7964,7 +7990,7 @@
                   <a:srgbClr val="1F2D3A"/>
                 </a:solidFill>
               </a:rPr>
-              <a:t>kendi bilgisayarınızda</a:t>
+              <a:t>only on your own computer</a:t>
             </a:r>
             <a:r>
               <a:rPr sz="2000" b="0">
@@ -7972,7 +7998,7 @@
                   <a:srgbClr val="1F2D3A"/>
                 </a:solidFill>
               </a:rPr>
-              <a:t> ve verilen demolar üzerinde denenir</a:t>
+              <a:t> and only on the demos provided</a:t>
             </a:r>
           </a:p>
         </p:txBody>

</xml_diff>